<commit_message>
docs: images and deck regenerate from committed scripts (Ruling BG)
scripts/screenshots.py gains --csm, --account, --docs, --height and
--crop; --docs shoots team before week (the CSM logs in after the team
shot) and the trace from the real recompute POST. scripts/deck.py
builds docs/deck/radar.pptx and reads it back (16:9, no 4:3 type, fit,
notes). week.png shows the behavioural why-now (Ruling BF); team.png no
longer shows a list opened by the screenshot run. The deck states the
renewal-sort claim per tenant. charts.py puts labels of short bars
above them and says why gbm is not plotted.
</commit_message>
<xml_diff>
--- a/docs/deck/radar.pptx
+++ b/docs/deck/radar.pptx
@@ -16,7 +16,7 @@
     <p:sldId id="264" r:id="rId16"/>
     <p:sldId id="265" r:id="rId17"/>
   </p:sldIdLst>
-  <p:sldSz cx="12191695" cy="6858000" type="screen4x3"/>
+  <p:sldSz cx="12191695" cy="6858000"/>
   <p:notesSz cx="6858000" cy="9144000"/>
   <p:defaultTextStyle>
     <a:defPPr>
@@ -721,7 +721,7 @@
           <a:lstStyle/>
           <a:p>
             <a:r>
-              <a:t>This is My week for one hearthline CSM, from the full-size database. Hard facts come first as must-act cases with a due date. A check-in covers an account we know too little about that renews soon. Then the model's slots fill the list to ten, each with its top reason and a draft that waits for the CSM.</a:t>
+              <a:t>This is My week for one hearthline CSM, from the full-size database. Hard facts come first as must-act cases with a due date. A check-in covers an account we know too little about that renews soon. Then the model's slots fill the list to ten, each with its top behavioural reason and a draft that waits for the CSM.</a:t>
             </a:r>
           </a:p>
         </p:txBody>
@@ -791,7 +791,7 @@
           <a:lstStyle/>
           <a:p>
             <a:r>
-              <a:t>Hard facts never wait for a model: they open a case with an owner and a due date. Then up to two check-ins for accounts we can't see that renew soon. The model fills what is left, ranked by p times ARR, and a slot needs at least the tenant's mean expected ARR at risk. Capacity is a cap, so a healthy book gets a shorter list, and the floor is on the ranking key, so it never reorders a list.</a:t>
+              <a:t>Hard facts never wait for a model: they open a case with an owner and a due date. Then up to two check-ins for accounts we can't see that renew soon. The model fills what is left, ranked by p times ARR, and a slot needs at least the tenant's mean expected ARR at risk. Capacity is a cap, so a healthy book gets a shorter list, and the floor is on the ranking key, so it never reorders a list. The 90 under a floor on p is in docs/measurements.md, from the earlier eval at commit f517b6c.</a:t>
             </a:r>
           </a:p>
         </p:txBody>
@@ -931,7 +931,7 @@
           <a:lstStyle/>
           <a:p>
             <a:r>
-              <a:t>Recall at K is the share of the ARR that went on to churn that was on a CSM's top ten that week, from a point-in-time backtest with rolling origins. The model beats the rules by about eight and nine points, and both intervals stay above zero. Renewal-date sort does worse than random, because accounts close to renewal have mostly already announced their decision and left the list. The VP's two lost renewals were on the model's lists 12 and 11 weeks ahead; renewal sort found them 2 weeks and 1 week ahead.</a:t>
+              <a:t>Recall at K is the share of the ARR that went on to churn that was on a CSM's top ten that week, from a point-in-time backtest with rolling origins. The model beats the rules by about eight and nine points, and both intervals stay above zero. Renewal-date sort does worse than random in hearthline, where its interval sits below random's, and no better than random in tallyworks, where the intervals overlap: accounts close to renewal have mostly already announced their decision and left the list. The VP's two lost renewals were on the model's lists 12 and 11 weeks ahead; renewal sort found them 2 weeks and 1 week ahead.</a:t>
             </a:r>
           </a:p>
         </p:txBody>
@@ -5528,7 +5528,7 @@
                 </a:solidFill>
                 <a:latin typeface="Arial"/>
               </a:rPr>
-              <a:t>The rest of the ten, ranked by expected ARR at risk. Each row shows its biggest reason, such as “support friction (90 days)”.</a:t>
+              <a:t>The rest of the ten, ranked by expected ARR at risk. Each row shows its biggest behavioural reason, such as “support friction (90 days)”.</a:t>
             </a:r>
           </a:p>
           <a:p>
@@ -6534,7 +6534,7 @@
                 </a:solidFill>
                 <a:latin typeface="Arial"/>
               </a:rPr>
-              <a:t>Renewal sort is worse than random </a:t>
+              <a:t>Renewal sort does worse than random in hearthline and no better than random in tallyworks, </a:t>
             </a:r>
             <a:r>
               <a:rPr sz="1400" b="0">
@@ -6543,7 +6543,7 @@
                 </a:solidFill>
                 <a:latin typeface="Arial"/>
               </a:rPr>
-              <a:t>because accounts close to renewal have mostly announced their decision already and left the list. The ones still there mostly renew.</a:t>
+              <a:t>because accounts close to renewal have mostly announced their decision already and left the list.</a:t>
             </a:r>
           </a:p>
           <a:p>

</xml_diff>

<commit_message>
docs: regenerate model cards, eval JSON, chart and deck after the eval fixes
Lead time counts flags inside the 90-day window; the backtest scores the deployed
model on settled labels. README, decisions, measurements and the deck
quote the new figures. The deck gives the measured book size (about 110).
</commit_message>
<xml_diff>
--- a/docs/deck/radar.pptx
+++ b/docs/deck/radar.pptx
@@ -931,7 +931,7 @@
           <a:lstStyle/>
           <a:p>
             <a:r>
-              <a:t>Recall at K is the share of the ARR that went on to churn that was on a CSM's top ten that week, from a point-in-time backtest with rolling origins. The model beats the rules by about eight and nine points, and both intervals stay above zero. Renewal-date sort does worse than random in hearthline, where its interval sits below random's, and no better than random in tallyworks, where the intervals overlap: accounts close to renewal have mostly already announced their decision and left the list. The VP's two lost renewals were on the model's lists 12 and 11 weeks ahead; renewal sort found them 2 weeks and 1 week ahead.</a:t>
+              <a:t>Recall at K is the share of the ARR that went on to churn that was on a CSM's top ten that week, from a point-in-time backtest with rolling origins. The model beats the rules by about eight and ten points, and both intervals stay above zero. Renewal-date sort does worse than random in hearthline, where its interval sits below random's, and no better than random in tallyworks, where the intervals overlap: accounts close to renewal have mostly already announced their decision and left the list. The VP's two lost renewals were on the model's lists 12 and 11 weeks ahead; renewal sort found them 2 weeks and 1 week ahead.</a:t>
             </a:r>
           </a:p>
         </p:txBody>
@@ -5080,7 +5080,7 @@
                 </a:solidFill>
                 <a:latin typeface="Arial"/>
               </a:rPr>
-              <a:t>A CSM owns about 120 accounts and has room for about ten proactive calls a week.</a:t>
+              <a:t>A CSM owns about 110 accounts (measured) and has room for about ten proactive calls a week.</a:t>
             </a:r>
           </a:p>
           <a:p>
@@ -5986,7 +5986,7 @@
                 </a:solidFill>
                 <a:latin typeface="Arial"/>
               </a:rPr>
-              <a:t>The cost: it catches more churned ARR but flags fewer small churners early. In tallyworks, 70 of 174 decisions were flagged ahead, against 90 under a floor on p.</a:t>
+              <a:t>The cost: it catches more churned ARR but flags fewer small churners early. In tallyworks (before the lead-time fix), 70 of 174 decisions were flagged ahead, against 90 under a floor on p.</a:t>
             </a:r>
           </a:p>
           <a:p>
@@ -6493,7 +6493,7 @@
                 </a:solidFill>
                 <a:latin typeface="Arial"/>
               </a:rPr>
-              <a:t>model 61.4% (52.9 to 68.0), rules 53.5%, renewal sort 14.7%. Model minus rules +7.9 points (+2.9 to +12.9).</a:t>
+              <a:t>model 61.6% (53.1 to 68.1), rules 53.5%, renewal sort 14.7%. Model minus rules +8.1 points (+3.2 to +13.1).</a:t>
             </a:r>
           </a:p>
           <a:p>
@@ -6518,7 +6518,7 @@
                 </a:solidFill>
                 <a:latin typeface="Arial"/>
               </a:rPr>
-              <a:t>model 59.1% (49.3 to 67.0), rules 49.7%, renewal sort 18.4%. Model minus rules +9.4 points (+2.0 to +17.3).</a:t>
+              <a:t>model 59.6% (49.8 to 67.9), rules 49.7%, renewal sort 18.4%. Model minus rules +9.8 points (+2.1 to +18.2).</a:t>
             </a:r>
           </a:p>
           <a:p>

</xml_diff>